<commit_message>
update to latest version
</commit_message>
<xml_diff>
--- a/submission/FasalProof_Pitch_Deck.pptx
+++ b/submission/FasalProof_Pitch_Deck.pptx
@@ -12,9 +12,10 @@
     <p:sldId id="260" r:id="rId6"/>
     <p:sldId id="261" r:id="rId7"/>
     <p:sldId id="262" r:id="rId8"/>
+    <p:sldId id="263" r:id="rId9"/>
   </p:sldIdLst>
   <p:notesMasterIdLst>
-    <p:notesMasterId r:id="rId9"/>
+    <p:notesMasterId r:id="rId10"/>
   </p:notesMasterIdLst>
   <p:sldSz cx="9144000" cy="5143500"/>
   <p:notesSz cx="5143500" cy="9144000"/>
@@ -113,35 +114,36 @@
   <p:extLst>
     <p:ext uri="{521415D9-36F7-43E2-AB2F-B90AF26B5E84}">
       <p14:sectionLst xmlns:p14="http://schemas.microsoft.com/office/powerpoint/2010/main">
-        <p14:section name="Open" id="{bfb68a4b-dca5-a3dd-1bcb-7c25b0a9320d}">
+        <p14:section name="Open" id="{50cbe143-0db9-9063-ada0-2fa22f8665ae}">
           <p14:sldIdLst>
             <p14:sldId id="256"/>
           </p14:sldIdLst>
         </p14:section>
-        <p14:section name="Problem" id="{f1c02239-e1d0-eafc-23c8-61f356db0c5e}">
+        <p14:section name="Problem" id="{e155b201-48e2-f05f-b94f-8dc74974dbc8}">
           <p14:sldIdLst>
             <p14:sldId id="257"/>
           </p14:sldIdLst>
         </p14:section>
-        <p14:section name="Solution" id="{46b27bee-bfa8-76cb-4f5a-f9914847c499}">
+        <p14:section name="Solution" id="{832ab9a1-619d-2513-b871-a1b3db25a519}">
           <p14:sldIdLst>
             <p14:sldId id="258"/>
           </p14:sldIdLst>
         </p14:section>
-        <p14:section name="Tech" id="{b2f79ee9-0dcd-2a32-7cbe-07562c642e31}">
+        <p14:section name="Tech" id="{7099c1a4-5ca9-d179-ddca-07bf2e0c3a28}">
           <p14:sldIdLst>
             <p14:sldId id="259"/>
             <p14:sldId id="260"/>
-          </p14:sldIdLst>
-        </p14:section>
-        <p14:section name="Trust" id="{e9d7638d-5d2e-d4c4-7e36-3567cda61708}">
-          <p14:sldIdLst>
             <p14:sldId id="261"/>
           </p14:sldIdLst>
         </p14:section>
-        <p14:section name="Close" id="{2c817e53-3376-5596-b047-43ec7daf854d}">
+        <p14:section name="Trust" id="{d3a815bd-0ca8-dab2-baf3-b78094f5ae16}">
           <p14:sldIdLst>
             <p14:sldId id="262"/>
+          </p14:sldIdLst>
+        </p14:section>
+        <p14:section name="Close" id="{20476355-e7c6-9a4e-edd1-9fc40d5dbecc}">
+          <p14:sldIdLst>
+            <p14:sldId id="263"/>
           </p14:sldIdLst>
         </p14:section>
       </p14:sectionLst>
@@ -988,7 +990,7 @@
           <a:p>
             <a:r>
               <a:rPr lang="en-US" dirty="0"/>
-              <a:t>Say the limits before a judge does. Spot checks on arbitrary no-event dates showed 14 to 19 percent apparent loss, which is why losses below about 25 percent are not treated as damage. The validation script and table template are in the repository.</a:t>
+              <a:t>Do not disparage dashboards: they answer a different question. Ours is event-conditioned and plot-level, and the output is something a farmer can submit: a signed report, the right claim route and deadline, and a letter in their language.</a:t>
             </a:r>
             <a:endParaRPr lang="en-US" dirty="0"/>
           </a:p>
@@ -1076,7 +1078,7 @@
           <a:p>
             <a:r>
               <a:rPr lang="en-US" dirty="0"/>
-              <a:t>Close with the one-line summary and invite them to open the site. Mention the roadmap in one breath. Be ready for: accuracy, cloud cover in monsoon, why free data, and what the tool cannot do.</a:t>
+              <a:t>Say the limits before a judge does. Real spot checks on three arbitrary dates reported 19.3, 14.1 and 13.7 percent apparent loss with intervals spanning zero, so losses below about 25 percent are not read as damage. That is n equals 3: a warning, not a false-positive rate. Quote the case-study controls from EVIDENCE.md as well. The validation script and table template are in the repository.</a:t>
             </a:r>
             <a:endParaRPr lang="en-US" dirty="0"/>
           </a:p>
@@ -1100,6 +1102,94 @@
             <a:fld id="{F7021451-1387-4CA6-816F-3879F97B5CBC}" type="slidenum">
               <a:rPr lang="en-US"/>
               <a:t>7</a:t>
+            </a:fld>
+            <a:endParaRPr lang="en-US"/>
+          </a:p>
+        </p:txBody>
+      </p:sp>
+    </p:spTree>
+    <p:extLst>
+      <p:ext uri="{BB962C8B-B14F-4D97-AF65-F5344CB8AC3E}">
+        <p14:creationId xmlns:p14="http://schemas.microsoft.com/office/powerpoint/2010/main" val="1024086991"/>
+      </p:ext>
+    </p:extLst>
+  </p:cSld>
+  <p:clrMapOvr>
+    <a:masterClrMapping/>
+  </p:clrMapOvr>
+</p:notes>
+</file>
+
+<file path=ppt/notesSlides/notesSlide8.xml><?xml version="1.0" encoding="utf-8"?>
+<p:notes xmlns:a="http://schemas.openxmlformats.org/drawingml/2006/main" xmlns:r="http://schemas.openxmlformats.org/officeDocument/2006/relationships" xmlns:p="http://schemas.openxmlformats.org/presentationml/2006/main">
+  <p:cSld>
+    <p:spTree>
+      <p:nvGrpSpPr>
+        <p:cNvPr id="1" name=""/>
+        <p:cNvGrpSpPr/>
+        <p:nvPr/>
+      </p:nvGrpSpPr>
+      <p:grpSpPr>
+        <a:xfrm>
+          <a:off x="0" y="0"/>
+          <a:ext cx="0" cy="0"/>
+          <a:chOff x="0" y="0"/>
+          <a:chExt cx="0" cy="0"/>
+        </a:xfrm>
+      </p:grpSpPr>
+      <p:sp>
+        <p:nvSpPr>
+          <p:cNvPr id="2" name="Slide Image Placeholder 1"/>
+          <p:cNvSpPr>
+            <a:spLocks noGrp="1" noRot="1" noChangeAspect="1"/>
+          </p:cNvSpPr>
+          <p:nvPr>
+            <p:ph type="sldImg"/>
+          </p:nvPr>
+        </p:nvSpPr>
+        <p:spPr/>
+      </p:sp>
+      <p:sp>
+        <p:nvSpPr>
+          <p:cNvPr id="3" name="Notes Placeholder 2"/>
+          <p:cNvSpPr>
+            <a:spLocks noGrp="1"/>
+          </p:cNvSpPr>
+          <p:nvPr>
+            <p:ph type="body" idx="1"/>
+          </p:nvPr>
+        </p:nvSpPr>
+        <p:spPr/>
+        <p:txBody>
+          <a:bodyPr/>
+          <a:lstStyle/>
+          <a:p>
+            <a:r>
+              <a:rPr lang="en-US" dirty="0"/>
+              <a:t>Close with the one-line summary and invite them to open the site. Mention the roadmap in one breath. Be ready for: accuracy, cloud cover in monsoon, why free data, and what the tool cannot do.</a:t>
+            </a:r>
+            <a:endParaRPr lang="en-US" dirty="0"/>
+          </a:p>
+        </p:txBody>
+      </p:sp>
+      <p:sp>
+        <p:nvSpPr>
+          <p:cNvPr id="4" name="Slide Number Placeholder 3"/>
+          <p:cNvSpPr>
+            <a:spLocks noGrp="1"/>
+          </p:cNvSpPr>
+          <p:nvPr>
+            <p:ph type="sldNum" sz="quarter" idx="10"/>
+          </p:nvPr>
+        </p:nvSpPr>
+        <p:spPr/>
+        <p:txBody>
+          <a:bodyPr/>
+          <a:lstStyle/>
+          <a:p>
+            <a:fld id="{F7021451-1387-4CA6-816F-3879F97B5CBC}" type="slidenum">
+              <a:rPr lang="en-US"/>
+              <a:t>8</a:t>
             </a:fld>
             <a:endParaRPr lang="en-US"/>
           </a:p>
@@ -5072,7 +5162,7 @@
                   <a:schemeClr val="tx1"/>
                 </a:solidFill>
               </a:rPr>
-              <a:t>Honest by design</a:t>
+              <a:t>More than a dashboard</a:t>
             </a:r>
             <a:endParaRPr lang="en-US" sz="3600" dirty="0"/>
           </a:p>
@@ -5080,7 +5170,7 @@
       </p:sp>
       <p:sp>
         <p:nvSpPr>
-          <p:cNvPr id="3" name="Limits card"/>
+          <p:cNvPr id="3" name="Dashboard card"/>
           <p:cNvSpPr/>
           <p:nvPr/>
         </p:nvSpPr>
@@ -5107,7 +5197,7 @@
       </p:sp>
       <p:sp>
         <p:nvSpPr>
-          <p:cNvPr id="4" name="Validation card"/>
+          <p:cNvPr id="4" name="FasalProof card"/>
           <p:cNvSpPr/>
           <p:nvPr/>
         </p:nvSpPr>
@@ -5122,11 +5212,11 @@
             </a:avLst>
           </a:prstGeom>
           <a:solidFill>
-            <a:schemeClr val="bg2"/>
+            <a:schemeClr val="tx1"/>
           </a:solidFill>
           <a:ln w="12700">
             <a:solidFill>
-              <a:schemeClr val="bg2"/>
+              <a:schemeClr val="tx1"/>
             </a:solidFill>
             <a:prstDash val="solid"/>
           </a:ln>
@@ -5162,7 +5252,7 @@
                   <a:schemeClr val="tx1"/>
                 </a:solidFill>
               </a:rPr>
-              <a:t>Limits we show on screen</a:t>
+              <a:t>A conventional dashboard</a:t>
             </a:r>
             <a:endParaRPr lang="en-US" sz="2000" dirty="0"/>
           </a:p>
@@ -5176,7 +5266,7 @@
         </p:nvSpPr>
         <p:spPr>
           <a:xfrm>
-            <a:off x="777240" y="2011680"/>
+            <a:off x="777240" y="2057400"/>
             <a:ext cx="3474720" cy="2286000"/>
           </a:xfrm>
           <a:prstGeom prst="rect">
@@ -5202,7 +5292,7 @@
                   <a:schemeClr val="tx2"/>
                 </a:solidFill>
               </a:rPr>
-              <a:t>Supporting evidence, not an official assessment</a:t>
+              <a:t>Aggregates by district or region</a:t>
             </a:r>
             <a:endParaRPr lang="en-US" sz="1400" dirty="0"/>
           </a:p>
@@ -5220,7 +5310,7 @@
                   <a:schemeClr val="tx2"/>
                 </a:solidFill>
               </a:rPr>
-              <a:t>No accuracy figure claimed yet</a:t>
+              <a:t>Asks: how is the season going?</a:t>
             </a:r>
             <a:endParaRPr lang="en-US" sz="1400" dirty="0"/>
           </a:p>
@@ -5238,7 +5328,7 @@
                   <a:schemeClr val="tx2"/>
                 </a:solidFill>
               </a:rPr>
-              <a:t>Stage data are regional averages</a:t>
+              <a:t>Leaves the charts to the viewer</a:t>
             </a:r>
             <a:endParaRPr lang="en-US" sz="1400" dirty="0"/>
           </a:p>
@@ -5256,7 +5346,7 @@
                   <a:schemeClr val="tx2"/>
                 </a:solidFill>
               </a:rPr>
-              <a:t>Rules and sum insured come from the policy</a:t>
+              <a:t>Output is a view</a:t>
             </a:r>
             <a:endParaRPr lang="en-US" sz="1400" dirty="0"/>
           </a:p>
@@ -5289,10 +5379,10 @@
             <a:r>
               <a:rPr lang="en-US" sz="2000" b="1" dirty="0">
                 <a:solidFill>
-                  <a:schemeClr val="tx1"/>
-                </a:solidFill>
-              </a:rPr>
-              <a:t>How we will validate</a:t>
+                  <a:schemeClr val="accent1"/>
+                </a:solidFill>
+              </a:rPr>
+              <a:t>FasalProof</a:t>
             </a:r>
             <a:endParaRPr lang="en-US" sz="2000" dirty="0"/>
           </a:p>
@@ -5306,7 +5396,7 @@
         </p:nvSpPr>
         <p:spPr>
           <a:xfrm>
-            <a:off x="4892040" y="2011680"/>
+            <a:off x="4892040" y="2057400"/>
             <a:ext cx="3474720" cy="2286000"/>
           </a:xfrm>
           <a:prstGeom prst="rect">
@@ -5329,10 +5419,10 @@
             <a:r>
               <a:rPr lang="en-US" sz="1400" dirty="0">
                 <a:solidFill>
-                  <a:schemeClr val="tx2"/>
-                </a:solidFill>
-              </a:rPr>
-              <a:t>Documented damaged fields plus no-event fields</a:t>
+                  <a:schemeClr val="bg1"/>
+                </a:solidFill>
+              </a:rPr>
+              <a:t>Starts from one plot and one loss date</a:t>
             </a:r>
             <a:endParaRPr lang="en-US" sz="1400" dirty="0"/>
           </a:p>
@@ -5347,10 +5437,10 @@
             <a:r>
               <a:rPr lang="en-US" sz="1400" dirty="0">
                 <a:solidFill>
-                  <a:schemeClr val="tx2"/>
-                </a:solidFill>
-              </a:rPr>
-              <a:t>Precision, recall and specificity</a:t>
+                  <a:schemeClr val="bg1"/>
+                </a:solidFill>
+              </a:rPr>
+              <a:t>Asks: was this field damaged, by how much, how sure are we?</a:t>
             </a:r>
             <a:endParaRPr lang="en-US" sz="1400" dirty="0"/>
           </a:p>
@@ -5365,10 +5455,10 @@
             <a:r>
               <a:rPr lang="en-US" sz="1400" dirty="0">
                 <a:solidFill>
-                  <a:schemeClr val="tx2"/>
-                </a:solidFill>
-              </a:rPr>
-              <a:t>Error against officially reported loss</a:t>
+                  <a:schemeClr val="bg1"/>
+                </a:solidFill>
+              </a:rPr>
+              <a:t>Adds local rain history, crop stage, claim route and deadline</a:t>
             </a:r>
             <a:endParaRPr lang="en-US" sz="1400" dirty="0"/>
           </a:p>
@@ -5383,10 +5473,10 @@
             <a:r>
               <a:rPr lang="en-US" sz="1400" dirty="0">
                 <a:solidFill>
-                  <a:schemeClr val="tx2"/>
-                </a:solidFill>
-              </a:rPr>
-              <a:t>Results published in the README</a:t>
+                  <a:schemeClr val="bg1"/>
+                </a:solidFill>
+              </a:rPr>
+              <a:t>Output is a signed evidence pack and a claim letter</a:t>
             </a:r>
             <a:endParaRPr lang="en-US" sz="1400" dirty="0"/>
           </a:p>
@@ -5448,6 +5538,428 @@
 <file path=ppt/slides/slide7.xml><?xml version="1.0" encoding="utf-8"?>
 <p:sld xmlns:a="http://schemas.openxmlformats.org/drawingml/2006/main" xmlns:r="http://schemas.openxmlformats.org/officeDocument/2006/relationships" xmlns:p="http://schemas.openxmlformats.org/presentationml/2006/main">
   <p:cSld name="Slide 7">
+    <p:spTree>
+      <p:nvGrpSpPr>
+        <p:cNvPr id="1" name=""/>
+        <p:cNvGrpSpPr/>
+        <p:nvPr/>
+      </p:nvGrpSpPr>
+      <p:grpSpPr>
+        <a:xfrm>
+          <a:off x="0" y="0"/>
+          <a:ext cx="0" cy="0"/>
+          <a:chOff x="0" y="0"/>
+          <a:chExt cx="0" cy="0"/>
+        </a:xfrm>
+      </p:grpSpPr>
+      <p:sp>
+        <p:nvSpPr>
+          <p:cNvPr id="2" name="Text 1"/>
+          <p:cNvSpPr/>
+          <p:nvPr>
+            <p:ph idx="101" type="title" hasCustomPrompt="1"/>
+          </p:nvPr>
+        </p:nvSpPr>
+        <p:spPr>
+          <a:xfrm>
+            <a:off x="548640" y="411480"/>
+            <a:ext cx="8046720" cy="731520"/>
+          </a:xfrm>
+          <a:prstGeom prst="rect">
+            <a:avLst/>
+          </a:prstGeom>
+          <a:noFill/>
+          <a:ln/>
+        </p:spPr>
+        <p:txBody>
+          <a:bodyPr wrap="square" lIns="0" tIns="0" rIns="0" bIns="0" rtlCol="0" anchor="t"/>
+          <a:lstStyle/>
+          <a:p>
+            <a:pPr algn="l" indent="0" marL="0">
+              <a:buNone/>
+            </a:pPr>
+            <a:r>
+              <a:rPr lang="en-US" sz="3600" b="1" dirty="0">
+                <a:solidFill>
+                  <a:schemeClr val="tx1"/>
+                </a:solidFill>
+              </a:rPr>
+              <a:t>Honest by design</a:t>
+            </a:r>
+            <a:endParaRPr lang="en-US" sz="3600" dirty="0"/>
+          </a:p>
+        </p:txBody>
+      </p:sp>
+      <p:sp>
+        <p:nvSpPr>
+          <p:cNvPr id="3" name="Limits card"/>
+          <p:cNvSpPr/>
+          <p:nvPr/>
+        </p:nvSpPr>
+        <p:spPr>
+          <a:xfrm>
+            <a:off x="548640" y="1371600"/>
+            <a:ext cx="3931920" cy="3108960"/>
+          </a:xfrm>
+          <a:prstGeom prst="roundRect">
+            <a:avLst>
+              <a:gd name="adj" fmla="val 3529"/>
+            </a:avLst>
+          </a:prstGeom>
+          <a:solidFill>
+            <a:schemeClr val="bg2"/>
+          </a:solidFill>
+          <a:ln w="12700">
+            <a:solidFill>
+              <a:schemeClr val="bg2"/>
+            </a:solidFill>
+            <a:prstDash val="solid"/>
+          </a:ln>
+        </p:spPr>
+      </p:sp>
+      <p:sp>
+        <p:nvSpPr>
+          <p:cNvPr id="4" name="Validation card"/>
+          <p:cNvSpPr/>
+          <p:nvPr/>
+        </p:nvSpPr>
+        <p:spPr>
+          <a:xfrm>
+            <a:off x="4663440" y="1371600"/>
+            <a:ext cx="3931920" cy="3108960"/>
+          </a:xfrm>
+          <a:prstGeom prst="roundRect">
+            <a:avLst>
+              <a:gd name="adj" fmla="val 3529"/>
+            </a:avLst>
+          </a:prstGeom>
+          <a:solidFill>
+            <a:schemeClr val="bg2"/>
+          </a:solidFill>
+          <a:ln w="12700">
+            <a:solidFill>
+              <a:schemeClr val="bg2"/>
+            </a:solidFill>
+            <a:prstDash val="solid"/>
+          </a:ln>
+        </p:spPr>
+      </p:sp>
+      <p:sp>
+        <p:nvSpPr>
+          <p:cNvPr id="5" name="Text 3"/>
+          <p:cNvSpPr txBox="1"/>
+          <p:nvPr/>
+        </p:nvSpPr>
+        <p:spPr>
+          <a:xfrm>
+            <a:off x="777240" y="1554480"/>
+            <a:ext cx="3474720" cy="365760"/>
+          </a:xfrm>
+          <a:prstGeom prst="rect">
+            <a:avLst/>
+          </a:prstGeom>
+          <a:noFill/>
+          <a:ln/>
+        </p:spPr>
+        <p:txBody>
+          <a:bodyPr wrap="square" lIns="0" tIns="0" rIns="0" bIns="0" rtlCol="0" anchor="ctr"/>
+          <a:lstStyle/>
+          <a:p>
+            <a:pPr indent="0" marL="0">
+              <a:buNone/>
+            </a:pPr>
+            <a:r>
+              <a:rPr lang="en-US" sz="2000" b="1" dirty="0">
+                <a:solidFill>
+                  <a:schemeClr val="tx1"/>
+                </a:solidFill>
+              </a:rPr>
+              <a:t>Limits we show on screen</a:t>
+            </a:r>
+            <a:endParaRPr lang="en-US" sz="2000" dirty="0"/>
+          </a:p>
+        </p:txBody>
+      </p:sp>
+      <p:sp>
+        <p:nvSpPr>
+          <p:cNvPr id="6" name="Text 4"/>
+          <p:cNvSpPr txBox="1"/>
+          <p:nvPr/>
+        </p:nvSpPr>
+        <p:spPr>
+          <a:xfrm>
+            <a:off x="777240" y="2011680"/>
+            <a:ext cx="3474720" cy="2286000"/>
+          </a:xfrm>
+          <a:prstGeom prst="rect">
+            <a:avLst/>
+          </a:prstGeom>
+          <a:noFill/>
+          <a:ln/>
+        </p:spPr>
+        <p:txBody>
+          <a:bodyPr wrap="square" lIns="0" tIns="0" rIns="0" bIns="0" rtlCol="0" anchor="t"/>
+          <a:lstStyle/>
+          <a:p>
+            <a:pPr marL="342900" indent="-342900">
+              <a:spcAft>
+                <a:spcPts val="800"/>
+              </a:spcAft>
+              <a:buSzPct val="100000"/>
+              <a:buChar char="•"/>
+            </a:pPr>
+            <a:r>
+              <a:rPr lang="en-US" sz="1400" dirty="0">
+                <a:solidFill>
+                  <a:schemeClr val="tx2"/>
+                </a:solidFill>
+              </a:rPr>
+              <a:t>Supporting evidence, not an official assessment</a:t>
+            </a:r>
+            <a:endParaRPr lang="en-US" sz="1400" dirty="0"/>
+          </a:p>
+          <a:p>
+            <a:pPr marL="342900" indent="-342900">
+              <a:spcAft>
+                <a:spcPts val="800"/>
+              </a:spcAft>
+              <a:buSzPct val="100000"/>
+              <a:buChar char="•"/>
+            </a:pPr>
+            <a:r>
+              <a:rPr lang="en-US" sz="1400" dirty="0">
+                <a:solidFill>
+                  <a:schemeClr val="tx2"/>
+                </a:solidFill>
+              </a:rPr>
+              <a:t>No accuracy figure claimed yet</a:t>
+            </a:r>
+            <a:endParaRPr lang="en-US" sz="1400" dirty="0"/>
+          </a:p>
+          <a:p>
+            <a:pPr marL="342900" indent="-342900">
+              <a:spcAft>
+                <a:spcPts val="800"/>
+              </a:spcAft>
+              <a:buSzPct val="100000"/>
+              <a:buChar char="•"/>
+            </a:pPr>
+            <a:r>
+              <a:rPr lang="en-US" sz="1400" dirty="0">
+                <a:solidFill>
+                  <a:schemeClr val="tx2"/>
+                </a:solidFill>
+              </a:rPr>
+              <a:t>Stage data are regional averages</a:t>
+            </a:r>
+            <a:endParaRPr lang="en-US" sz="1400" dirty="0"/>
+          </a:p>
+          <a:p>
+            <a:pPr marL="342900" indent="-342900">
+              <a:spcAft>
+                <a:spcPts val="800"/>
+              </a:spcAft>
+              <a:buSzPct val="100000"/>
+              <a:buChar char="•"/>
+            </a:pPr>
+            <a:r>
+              <a:rPr lang="en-US" sz="1400" dirty="0">
+                <a:solidFill>
+                  <a:schemeClr val="tx2"/>
+                </a:solidFill>
+              </a:rPr>
+              <a:t>Rules and sum insured come from the policy</a:t>
+            </a:r>
+            <a:endParaRPr lang="en-US" sz="1400" dirty="0"/>
+          </a:p>
+        </p:txBody>
+      </p:sp>
+      <p:sp>
+        <p:nvSpPr>
+          <p:cNvPr id="7" name="Text 5"/>
+          <p:cNvSpPr txBox="1"/>
+          <p:nvPr/>
+        </p:nvSpPr>
+        <p:spPr>
+          <a:xfrm>
+            <a:off x="4892040" y="1554480"/>
+            <a:ext cx="3474720" cy="365760"/>
+          </a:xfrm>
+          <a:prstGeom prst="rect">
+            <a:avLst/>
+          </a:prstGeom>
+          <a:noFill/>
+          <a:ln/>
+        </p:spPr>
+        <p:txBody>
+          <a:bodyPr wrap="square" lIns="0" tIns="0" rIns="0" bIns="0" rtlCol="0" anchor="ctr"/>
+          <a:lstStyle/>
+          <a:p>
+            <a:pPr indent="0" marL="0">
+              <a:buNone/>
+            </a:pPr>
+            <a:r>
+              <a:rPr lang="en-US" sz="2000" b="1" dirty="0">
+                <a:solidFill>
+                  <a:schemeClr val="tx1"/>
+                </a:solidFill>
+              </a:rPr>
+              <a:t>How we will validate</a:t>
+            </a:r>
+            <a:endParaRPr lang="en-US" sz="2000" dirty="0"/>
+          </a:p>
+        </p:txBody>
+      </p:sp>
+      <p:sp>
+        <p:nvSpPr>
+          <p:cNvPr id="8" name="Text 6"/>
+          <p:cNvSpPr txBox="1"/>
+          <p:nvPr/>
+        </p:nvSpPr>
+        <p:spPr>
+          <a:xfrm>
+            <a:off x="4892040" y="2011680"/>
+            <a:ext cx="3474720" cy="2286000"/>
+          </a:xfrm>
+          <a:prstGeom prst="rect">
+            <a:avLst/>
+          </a:prstGeom>
+          <a:noFill/>
+          <a:ln/>
+        </p:spPr>
+        <p:txBody>
+          <a:bodyPr wrap="square" lIns="0" tIns="0" rIns="0" bIns="0" rtlCol="0" anchor="t"/>
+          <a:lstStyle/>
+          <a:p>
+            <a:pPr marL="342900" indent="-342900">
+              <a:spcAft>
+                <a:spcPts val="800"/>
+              </a:spcAft>
+              <a:buSzPct val="100000"/>
+              <a:buChar char="•"/>
+            </a:pPr>
+            <a:r>
+              <a:rPr lang="en-US" sz="1400" dirty="0">
+                <a:solidFill>
+                  <a:schemeClr val="tx2"/>
+                </a:solidFill>
+              </a:rPr>
+              <a:t>Documented damaged fields plus no-event fields</a:t>
+            </a:r>
+            <a:endParaRPr lang="en-US" sz="1400" dirty="0"/>
+          </a:p>
+          <a:p>
+            <a:pPr marL="342900" indent="-342900">
+              <a:spcAft>
+                <a:spcPts val="800"/>
+              </a:spcAft>
+              <a:buSzPct val="100000"/>
+              <a:buChar char="•"/>
+            </a:pPr>
+            <a:r>
+              <a:rPr lang="en-US" sz="1400" dirty="0">
+                <a:solidFill>
+                  <a:schemeClr val="tx2"/>
+                </a:solidFill>
+              </a:rPr>
+              <a:t>Precision, recall and specificity</a:t>
+            </a:r>
+            <a:endParaRPr lang="en-US" sz="1400" dirty="0"/>
+          </a:p>
+          <a:p>
+            <a:pPr marL="342900" indent="-342900">
+              <a:spcAft>
+                <a:spcPts val="800"/>
+              </a:spcAft>
+              <a:buSzPct val="100000"/>
+              <a:buChar char="•"/>
+            </a:pPr>
+            <a:r>
+              <a:rPr lang="en-US" sz="1400" dirty="0">
+                <a:solidFill>
+                  <a:schemeClr val="tx2"/>
+                </a:solidFill>
+              </a:rPr>
+              <a:t>Error against officially reported loss</a:t>
+            </a:r>
+            <a:endParaRPr lang="en-US" sz="1400" dirty="0"/>
+          </a:p>
+          <a:p>
+            <a:pPr marL="342900" indent="-342900">
+              <a:spcAft>
+                <a:spcPts val="800"/>
+              </a:spcAft>
+              <a:buSzPct val="100000"/>
+              <a:buChar char="•"/>
+            </a:pPr>
+            <a:r>
+              <a:rPr lang="en-US" sz="1400" dirty="0">
+                <a:solidFill>
+                  <a:schemeClr val="tx2"/>
+                </a:solidFill>
+              </a:rPr>
+              <a:t>Results published in the README</a:t>
+            </a:r>
+            <a:endParaRPr lang="en-US" sz="1400" dirty="0"/>
+          </a:p>
+        </p:txBody>
+      </p:sp>
+      <p:sp>
+        <p:nvSpPr>
+          <p:cNvPr id="25" name="Slide Number Placeholder 0"/>
+          <p:cNvSpPr>
+            <a:spLocks noGrp="1"/>
+          </p:cNvSpPr>
+          <p:nvPr>
+            <p:ph type="sldNum" sz="quarter" idx="4294967295"/>
+          </p:nvPr>
+        </p:nvSpPr>
+        <p:spPr>
+          <a:xfrm>
+            <a:off x="8412480" y="4800600"/>
+            <a:ext cx="457200" cy="228600"/>
+          </a:xfrm>
+          <a:prstGeom prst="rect">
+            <a:avLst/>
+          </a:prstGeom>
+          <a:extLst>
+            <a:ext uri="{C572A759-6A51-4108-AA02-DFA0A04FC94B}">
+              <ma14:wrappingTextBoxFlag xmlns:ma14="http://schemas.microsoft.com/office/mac/drawingml/2011/main" val="0"/>
+            </a:ext>
+          </a:extLst>
+        </p:spPr>
+        <p:txBody>
+          <a:bodyPr/>
+          <a:lstStyle>
+            <a:lvl1pPr>
+              <a:defRPr sz="1000">
+                <a:solidFill>
+                  <a:schemeClr val="tx2"/>
+                </a:solidFill>
+              </a:defRPr>
+            </a:lvl1pPr>
+          </a:lstStyle>
+          <a:p>
+            <a:pPr algn="l"/>
+            <a:fld id="{F7021451-1387-4CA6-816F-3879F97B5CBC}" type="slidenum">
+              <a:rPr b="0" lang="en-US"/>
+              <a:t>7</a:t>
+            </a:fld>
+            <a:endParaRPr lang="en-US"/>
+          </a:p>
+        </p:txBody>
+      </p:sp>
+    </p:spTree>
+  </p:cSld>
+  <p:clrMapOvr>
+    <a:masterClrMapping/>
+  </p:clrMapOvr>
+</p:sld>
+</file>
+
+<file path=ppt/slides/slide8.xml><?xml version="1.0" encoding="utf-8"?>
+<p:sld xmlns:a="http://schemas.openxmlformats.org/drawingml/2006/main" xmlns:r="http://schemas.openxmlformats.org/officeDocument/2006/relationships" xmlns:p="http://schemas.openxmlformats.org/presentationml/2006/main">
+  <p:cSld name="Slide 8">
     <p:spTree>
       <p:nvGrpSpPr>
         <p:cNvPr id="1" name=""/>

</xml_diff>